<commit_message>
Rename Quotes to Sales Estimates; auto-convert on acceptance
Terminology: rename "Quotes" to "Sales Estimates" across the portal app
and all requirement/ticket/planning docs (incl. Sales Portal). Route
/quotes -> /sales-estimates, mock IDs QT-#### -> SE-####, and all nav,
dashboard, catalog cart, support, orders, and reorder labels updated.
"Competitor quote" (a pricing reason) is intentionally left unchanged.

Lifecycle rework:
- PCS acceptance now automatically converts a sales estimate into a sales
  order — the manual "Convert to Order" step is removed (app + CQ-08 +
  US-97 reworded).
- Counter-offers now offer Accept / Decline / Counter (previously only
  Accept / Decline). Accepting auto-converts; countering sends revised
  pricing back to PCS. New US-109 / UC-109; CQ-07 and status tables updated.

Docs: Requirements Stage 2 -> v1.2, Feature Tickets -> v1.4; PDFs and the
overview PPTX regenerated.

Co-Authored-By: Claude Opus 4.8 (1M context) <noreply@anthropic.com>
</commit_message>
<xml_diff>
--- a/PCS-Customer-Portal-Stage2-Stage3-Overview.pptx
+++ b/PCS-Customer-Portal-Stage2-Stage3-Overview.pptx
@@ -1548,7 +1548,7 @@
                             <a:srgbClr val="1E293B"/>
                           </a:solidFill>
                         </a:rPr>
-                        <a:t>Catalog, Quotes &amp; Offers</a:t>
+                        <a:t>Catalog, Sales Estimates &amp; Offers</a:t>
                       </a:r>
                       <a:endParaRPr lang="en-US" sz="1300" dirty="0"/>
                     </a:p>
@@ -1606,7 +1606,7 @@
                             <a:srgbClr val="334155"/>
                           </a:solidFill>
                         </a:rPr>
-                        <a:t>Browse catalog, build &amp; submit quotes, promotional offers — US-90–US-99</a:t>
+                        <a:t>Browse catalog, build &amp; submit sales estimates, promotional offers — US-90–US-99</a:t>
                       </a:r>
                       <a:endParaRPr lang="en-US" sz="1300" dirty="0"/>
                     </a:p>

</xml_diff>